<commit_message>
Usar 10M eventos reales de REES46 en todos los entregables
Corrida de punta a punta con 2019-Oct.csv (10.223.169 eventos, 1.246 s):
informe LaTeX, diapositivas, README y capturas del panel actualizados.
La corrida sintética se conserva como summary_10M_sintetico.json.

Co-Authored-By: Claude Opus 5.5 (1M context) <noreply@anthropic.com>
Claude-Session: https://claude.ai/code/session_01NFTbUrqWeiuDcqy8NmZF6c
</commit_message>
<xml_diff>
--- a/report/Presentacion_Final.pptx
+++ b/report/Presentacion_Final.pptx
@@ -119,19 +119,19 @@
   <p:extLst>
     <p:ext uri="{521415D9-36F7-43E2-AB2F-B90AF26B5E84}">
       <p14:sectionLst xmlns:p14="http://schemas.microsoft.com/office/powerpoint/2010/main">
-        <p14:section name="Introducción" id="{bf5d3fe0-6fb3-ab90-9437-78c2740f10ba}">
+        <p14:section name="Introducción" id="{8738394a-c9b4-9152-35aa-ad3c0eed0920}">
           <p14:sldIdLst>
             <p14:sldId id="256"/>
             <p14:sldId id="257"/>
             <p14:sldId id="258"/>
           </p14:sldIdLst>
         </p14:section>
-        <p14:section name="Arquitectura" id="{a4943e26-3c99-9c09-13ae-6360c946e3aa}">
+        <p14:section name="Arquitectura" id="{02fa399c-3c18-9474-5772-aea7826d4cba}">
           <p14:sldIdLst>
             <p14:sldId id="259"/>
           </p14:sldIdLst>
         </p14:section>
-        <p14:section name="Etapas" id="{fc972e2b-e9e3-2af6-78db-8da38a6a0208}">
+        <p14:section name="Etapas" id="{5f0f3740-f894-d0e8-7462-ec4ccc5e64b8}">
           <p14:sldIdLst>
             <p14:sldId id="260"/>
             <p14:sldId id="261"/>
@@ -140,14 +140,14 @@
             <p14:sldId id="264"/>
           </p14:sldIdLst>
         </p14:section>
-        <p14:section name="Resultados" id="{778f1b7d-13c1-4b21-798e-d7ca68e83c64}">
+        <p14:section name="Resultados" id="{dbdc4c92-881c-f91b-7818-1024676bcbc5}">
           <p14:sldIdLst>
             <p14:sldId id="265"/>
             <p14:sldId id="266"/>
             <p14:sldId id="267"/>
           </p14:sldIdLst>
         </p14:section>
-        <p14:section name="Cierre" id="{5fafd4f3-1e53-5137-9f47-f40b785f8366}">
+        <p14:section name="Cierre" id="{7c7e9005-ebf3-9fbc-7b3f-1cacafafcc0e}">
           <p14:sldIdLst>
             <p14:sldId id="268"/>
           </p14:sldIdLst>
@@ -1088,7 +1088,7 @@
                 <c:ptCount val="2"/>
                 <c:lvl>
                   <c:pt idx="0">
-                    <c:v>Pipeline 10M</c:v>
+                    <c:v>REES46 real (10M eventos)</c:v>
                   </c:pt>
                   <c:pt idx="1">
                     <c:v>Grafo plantado 1.0M aristas</c:v>
@@ -1104,7 +1104,7 @@
                 <c:formatCode>General</c:formatCode>
                 <c:ptCount val="2"/>
                 <c:pt idx="0">
-                  <c:v>0.916</c:v>
+                  <c:v>0.626</c:v>
                 </c:pt>
                 <c:pt idx="1">
                   <c:v>0.781</c:v>
@@ -1165,7 +1165,7 @@
                 <c:ptCount val="2"/>
                 <c:lvl>
                   <c:pt idx="0">
-                    <c:v>Pipeline 10M</c:v>
+                    <c:v>REES46 real (10M eventos)</c:v>
                   </c:pt>
                   <c:pt idx="1">
                     <c:v>Grafo plantado 1.0M aristas</c:v>
@@ -1181,7 +1181,7 @@
                 <c:formatCode>General</c:formatCode>
                 <c:ptCount val="2"/>
                 <c:pt idx="0">
-                  <c:v>0.894</c:v>
+                  <c:v>0.394</c:v>
                 </c:pt>
                 <c:pt idx="1">
                   <c:v>0.75</c:v>
@@ -1456,16 +1456,16 @@
                     <c:v>S8 grafo</c:v>
                   </c:pt>
                   <c:pt idx="3">
+                    <c:v>S8 refresco PageRank+Louvain</c:v>
+                  </c:pt>
+                  <c:pt idx="4">
                     <c:v>S5 refresco KD-Tree</c:v>
                   </c:pt>
-                  <c:pt idx="4">
+                  <c:pt idx="5">
                     <c:v>S4 B+Tree</c:v>
                   </c:pt>
-                  <c:pt idx="5">
+                  <c:pt idx="6">
                     <c:v>S9 servicio</c:v>
-                  </c:pt>
-                  <c:pt idx="6">
-                    <c:v>S8 refresco PageRank+Louvain</c:v>
                   </c:pt>
                   <c:pt idx="7">
                     <c:v>S3 almacenamiento</c:v>
@@ -1474,13 +1474,13 @@
                     <c:v>S3 interacciones</c:v>
                   </c:pt>
                   <c:pt idx="9">
+                    <c:v>S6 filtrado</c:v>
+                  </c:pt>
+                  <c:pt idx="10">
                     <c:v>S1 preprocesamiento</c:v>
                   </c:pt>
-                  <c:pt idx="10">
+                  <c:pt idx="11">
                     <c:v>S2 prioridad</c:v>
-                  </c:pt>
-                  <c:pt idx="11">
-                    <c:v>S6 filtrado</c:v>
                   </c:pt>
                   <c:pt idx="12">
                     <c:v>S0 ingesta</c:v>
@@ -1505,40 +1505,40 @@
                   <c:v>0.4</c:v>
                 </c:pt>
                 <c:pt idx="2">
-                  <c:v>1.9</c:v>
+                  <c:v>1.5</c:v>
                 </c:pt>
                 <c:pt idx="3">
-                  <c:v>4</c:v>
+                  <c:v>2.2</c:v>
                 </c:pt>
                 <c:pt idx="4">
-                  <c:v>4.8</c:v>
+                  <c:v>2.6</c:v>
                 </c:pt>
                 <c:pt idx="5">
-                  <c:v>5.7</c:v>
+                  <c:v>3.8</c:v>
                 </c:pt>
                 <c:pt idx="6">
-                  <c:v>20.8</c:v>
+                  <c:v>6.7</c:v>
                 </c:pt>
                 <c:pt idx="7">
-                  <c:v>28.1</c:v>
+                  <c:v>38</c:v>
                 </c:pt>
                 <c:pt idx="8">
-                  <c:v>53.1</c:v>
+                  <c:v>45.9</c:v>
                 </c:pt>
                 <c:pt idx="9">
-                  <c:v>63.7</c:v>
+                  <c:v>50.3</c:v>
                 </c:pt>
                 <c:pt idx="10">
-                  <c:v>78.1</c:v>
+                  <c:v>69.5</c:v>
                 </c:pt>
                 <c:pt idx="11">
-                  <c:v>86.8</c:v>
+                  <c:v>78.6</c:v>
                 </c:pt>
                 <c:pt idx="12">
-                  <c:v>244.4</c:v>
+                  <c:v>258.5</c:v>
                 </c:pt>
                 <c:pt idx="13">
-                  <c:v>781.1</c:v>
+                  <c:v>680.1</c:v>
                 </c:pt>
               </c:numCache>
             </c:numRef>
@@ -2348,7 +2348,7 @@
           <a:p>
             <a:r>
               <a:rPr lang="en-US" dirty="0"/>
-              <a:t>Presenta: Ronald. Corrimos los 10 millones de eventos de punta a punta. El gráfico muestra dónde se va el tiempo: la ingesta y el refresco de similitud son lo más caro; las estructuras de consulta como el B+Tree o el KD-Tree cuestan segundos. Esto nos dice qué optimizar primero.</a:t>
+              <a:t>Presenta: Ronald. Corrimos los 10 millones de eventos reales de punta a punta. El gráfico muestra dónde se va el tiempo: la ingesta y el refresco de similitud son lo más caro; las estructuras de consulta como el B+Tree o el KD-Tree cuestan segundos. Esto nos dice qué optimizar primero.</a:t>
             </a:r>
             <a:endParaRPr lang="en-US" dirty="0"/>
           </a:p>
@@ -2436,7 +2436,7 @@
           <a:p>
             <a:r>
               <a:rPr lang="en-US" dirty="0"/>
-              <a:t>Presenta: Clinton. Cerramos con cuatro ideas: la integración es observable de punta a punta, las estructuras probabilísticas ganan en memoria y tiempo con error controlado, las mediciones confirman la complejidad teórica, y el siguiente paso es correr sobre el dataset real y paralelizar el refresco de similitud. Gracias, quedamos atentos a sus preguntas.</a:t>
+              <a:t>Presenta: Clinton. Cerramos con cuatro ideas: la integración es observable de punta a punta, las estructuras probabilísticas ganan en memoria y tiempo con error controlado, las mediciones confirman la complejidad teórica, y el siguiente paso es procesar los dos meses completos y paralelizar el refresco de similitud. Gracias, quedamos atentos a sus preguntas.</a:t>
             </a:r>
             <a:endParaRPr lang="en-US" dirty="0"/>
           </a:p>
@@ -2612,7 +2612,7 @@
           <a:p>
             <a:r>
               <a:rPr lang="en-US" dirty="0"/>
-              <a:t>Presenta: Dante. Usamos el esquema de REES46. Encima agregamos lo que el dataset no trae y que el enunciado pide simular: dispositivo, tarjeta, tipo de envío, duplicados y ráfagas de fraude. Las etiquetas de fraude y duplicado solo se usan para medir precisión y recall, nunca para decidir.</a:t>
+              <a:t>Presenta: Dante. Usamos los primeros 10 millones de eventos reales de REES46, del 1 al 8 de octubre de 2019. Encima agregamos lo que el dataset no trae y que el enunciado pide simular: dispositivo, tarjeta, tipo de envío, duplicados y ráfagas de fraude. Las etiquetas de fraude y duplicado solo se usan para medir precisión y recall, nunca para decidir.</a:t>
             </a:r>
             <a:endParaRPr lang="en-US" dirty="0"/>
           </a:p>
@@ -2964,7 +2964,7 @@
           <a:p>
             <a:r>
               <a:rPr lang="en-US" dirty="0"/>
-              <a:t>Presenta: Clinton. El Bloom guarda la lista negra en pocos kilobytes y no tiene falsos negativos. Como un falso positivo bloquearía una compra legítima, cada positivo se verifica contra el conjunto exacto. El Count-Min cuenta intentos por tarjeta en una ventana deslizante de 10 minutos; nunca subestima, así que no oculta una ráfaga. El recall es 91 % porque los primeros intentos de cada ráfaga pasan antes de llegar al umbral.</a:t>
+              <a:t>Presenta: Clinton. El Bloom guarda la lista negra en pocos kilobytes y no tiene falsos negativos. Como un falso positivo bloquearía una compra legítima, cada positivo se verifica contra el conjunto exacto. El Count-Min cuenta intentos por tarjeta en una ventana deslizante de 10 minutos; nunca subestima, así que no oculta una ráfaga. El recall es 91 % porque los primeros intentos de cada ráfaga pasan antes de llegar al umbral. La precisión es 93 % porque en los datos reales hay unas 300 cuentas con hasta 110 carritos o compras en 10 minutos: parecen bots o revendedores, y en producción irían a revisión manual. Con datos sintéticos la precisión fue 99,998 %.</a:t>
             </a:r>
             <a:endParaRPr lang="en-US" dirty="0"/>
           </a:p>
@@ -3140,7 +3140,7 @@
           <a:p>
             <a:r>
               <a:rPr lang="en-US" dirty="0"/>
-              <a:t>Presenta: Clinton. El grafo une productos que aparecen en la misma orden. PageRank converge en menos de un segundo sobre el grafo de la corrida completa. En comunidades, Louvain obtiene mayor modularidad y es más estable entre semillas que Label Propagation, a cambio de más tiempo.</a:t>
+              <a:t>Presenta: Clinton. El grafo une productos que aparecen en la misma orden. PageRank converge en menos de un segundo. En los datos reales el grafo es disperso porque pocas sesiones compran más de un producto, y ahí la ventaja de Louvain sobre Label Propagation crece. En comunidades, Louvain obtiene mayor modularidad y es más estable entre semillas que Label Propagation, a cambio de más tiempo.</a:t>
             </a:r>
             <a:endParaRPr lang="en-US" dirty="0"/>
           </a:p>
@@ -6457,7 +6457,7 @@
                 <a:ea typeface="Courier New" pitchFamily="34" charset="-122"/>
                 <a:cs typeface="Courier New" pitchFamily="34" charset="-120"/>
               </a:rPr>
-              <a:t>Event(id=7050005, purchase, product=1326857, user=512393910, price=132.88)</a:t>
+              <a:t>Event(id=6966919, purchase, product=1004856, user=528344847, price=131.76)</a:t>
             </a:r>
             <a:endParaRPr lang="en-US" sz="1100" dirty="0"/>
           </a:p>
@@ -6477,7 +6477,7 @@
                 <a:ea typeface="Courier New" pitchFamily="34" charset="-122"/>
                 <a:cs typeface="Courier New" pitchFamily="34" charset="-120"/>
               </a:rPr>
-              <a:t>[S0] encolado (cola=545)</a:t>
+              <a:t>[S0] encolado (cola=1413)</a:t>
             </a:r>
             <a:endParaRPr lang="en-US" sz="1100" dirty="0"/>
           </a:p>
@@ -6517,7 +6517,7 @@
                 <a:ea typeface="Courier New" pitchFamily="34" charset="-122"/>
                 <a:cs typeface="Courier New" pitchFamily="34" charset="-120"/>
               </a:rPr>
-              <a:t>[S2] prioridad 0 (compra express), posición 3 de 4917 en el lote</a:t>
+              <a:t>[S2] prioridad 3 (compra programada), posición 133 de 4929 en el lote</a:t>
             </a:r>
             <a:endParaRPr lang="en-US" sz="1100" dirty="0"/>
           </a:p>
@@ -6537,7 +6537,7 @@
                 <a:ea typeface="Courier New" pitchFamily="34" charset="-122"/>
                 <a:cs typeface="Courier New" pitchFamily="34" charset="-120"/>
               </a:rPr>
-              <a:t>[S3] producto #46693 y usuario #58009 resueltos en la tabla hash</a:t>
+              <a:t>[S3] producto #861 y usuario #746718 resueltos en la tabla hash</a:t>
             </a:r>
             <a:endParaRPr lang="en-US" sz="1100" dirty="0"/>
           </a:p>
@@ -6597,7 +6597,7 @@
                 <a:ea typeface="Courier New" pitchFamily="34" charset="-122"/>
                 <a:cs typeface="Courier New" pitchFamily="34" charset="-120"/>
               </a:rPr>
-              <a:t>[S5] vecinos por atributos (KD-Tree): [108810, 11894, 67409]</a:t>
+              <a:t>[S5] vecinos por atributos (KD-Tree): [786, 840, 14608]</a:t>
             </a:r>
             <a:endParaRPr lang="en-US" sz="1100" dirty="0"/>
           </a:p>
@@ -6617,7 +6617,7 @@
                 <a:ea typeface="Courier New" pitchFamily="34" charset="-122"/>
                 <a:cs typeface="Courier New" pitchFamily="34" charset="-120"/>
               </a:rPr>
-              <a:t>[S7] relacionados LSH: []; vecinos IVF: [180133, 171512, 125502]</a:t>
+              <a:t>[S7] relacionados LSH: []; vecinos IVF: [87190, 87862, 40728]</a:t>
             </a:r>
             <a:endParaRPr lang="en-US" sz="1100" dirty="0"/>
           </a:p>
@@ -6637,7 +6637,7 @@
                 <a:ea typeface="Courier New" pitchFamily="34" charset="-122"/>
                 <a:cs typeface="Courier New" pitchFamily="34" charset="-120"/>
               </a:rPr>
-              <a:t>[S8] co-compra con [143273, 99174, 32717] en la misma orden</a:t>
+              <a:t>[S8] primera compra de la orden: nodo listo para nuevas aristas</a:t>
             </a:r>
             <a:endParaRPr lang="en-US" sz="1100" dirty="0"/>
           </a:p>
@@ -6769,7 +6769,7 @@
                   <a:schemeClr val="tx1"/>
                 </a:solidFill>
               </a:rPr>
-              <a:t>La corrida completa: 10.2M eventos en 23 minutos</a:t>
+              <a:t>La corrida completa: 10.2M eventos reales en 21 minutos</a:t>
             </a:r>
             <a:endParaRPr lang="en-US" sz="2800" dirty="0"/>
           </a:p>
@@ -6824,7 +6824,7 @@
                 <a:ea typeface="Cambria" pitchFamily="34" charset="-122"/>
                 <a:cs typeface="Cambria" pitchFamily="34" charset="-120"/>
               </a:rPr>
-              <a:t>7,402 ev/s</a:t>
+              <a:t>8,204 ev/s</a:t>
             </a:r>
             <a:endParaRPr lang="en-US" sz="3600" dirty="0"/>
           </a:p>
@@ -6899,7 +6899,7 @@
                 <a:ea typeface="Cambria" pitchFamily="34" charset="-122"/>
                 <a:cs typeface="Cambria" pitchFamily="34" charset="-120"/>
               </a:rPr>
-              <a:t>254,328</a:t>
+              <a:t>178,145</a:t>
             </a:r>
             <a:endParaRPr lang="en-US" sz="3600" dirty="0"/>
           </a:p>
@@ -6974,7 +6974,7 @@
                 <a:ea typeface="Cambria" pitchFamily="34" charset="-122"/>
                 <a:cs typeface="Cambria" pitchFamily="34" charset="-120"/>
               </a:rPr>
-              <a:t>64,923</a:t>
+              <a:t>70,682</a:t>
             </a:r>
             <a:endParaRPr lang="en-US" sz="3600" dirty="0"/>
           </a:p>
@@ -7046,7 +7046,7 @@
                   <a:schemeClr val="tx2"/>
                 </a:solidFill>
               </a:rPr>
-              <a:t>El refresco de S7 (SVD + k-means sobre 200K productos) domina el tiempo: es el primer candidato a paralelizar.</a:t>
+              <a:t>El refresco de S7 (SVD + k-means sobre la matriz usuario × producto) domina el tiempo: es el primer candidato a paralelizar.</a:t>
             </a:r>
             <a:endParaRPr lang="en-US" sz="1250" dirty="0"/>
           </a:p>
@@ -7706,7 +7706,7 @@
                   <a:schemeClr val="accent6"/>
                 </a:solidFill>
               </a:rPr>
-              <a:t>Correr sobre REES46 real, paralelizar el refresco de S7 y probar Leiden frente a Louvain.</a:t>
+              <a:t>Procesar octubre y noviembre completos (110M eventos), calibrar el umbral por usuario y paralelizar S7.</a:t>
             </a:r>
             <a:endParaRPr lang="en-US" sz="1400" dirty="0"/>
           </a:p>
@@ -8509,7 +8509,7 @@
                   <a:schemeClr val="tx1"/>
                 </a:solidFill>
               </a:rPr>
-              <a:t>Datos: el esquema de REES46 más el componente de stream</a:t>
+              <a:t>Datos: 10M eventos reales de REES46 más el componente de stream</a:t>
             </a:r>
             <a:endParaRPr lang="en-US" sz="2800" dirty="0"/>
           </a:p>
@@ -8548,7 +8548,7 @@
                 <a:ea typeface="Cambria" pitchFamily="34" charset="-122"/>
                 <a:cs typeface="Cambria" pitchFamily="34" charset="-120"/>
               </a:rPr>
-              <a:t>10,222,591</a:t>
+              <a:t>10,223,169</a:t>
             </a:r>
             <a:endParaRPr lang="en-US" sz="3600" dirty="0"/>
           </a:p>
@@ -8584,7 +8584,7 @@
                   <a:schemeClr val="tx2"/>
                 </a:solidFill>
               </a:rPr>
-              <a:t>eventos procesados en la corrida completa</a:t>
+              <a:t>eventos reales del 1 al 8 de octubre de 2019</a:t>
             </a:r>
             <a:endParaRPr lang="en-US" sz="1250" dirty="0"/>
           </a:p>
@@ -8623,7 +8623,7 @@
                 <a:ea typeface="Cambria" pitchFamily="34" charset="-122"/>
                 <a:cs typeface="Cambria" pitchFamily="34" charset="-120"/>
               </a:rPr>
-              <a:t>200,000</a:t>
+              <a:t>120,565</a:t>
             </a:r>
             <a:endParaRPr lang="en-US" sz="3600" dirty="0"/>
           </a:p>
@@ -8659,7 +8659,7 @@
                   <a:schemeClr val="tx2"/>
                 </a:solidFill>
               </a:rPr>
-              <a:t>productos y 401,260 usuarios</a:t>
+              <a:t>productos y 1,072,341 usuarios</a:t>
             </a:r>
             <a:endParaRPr lang="en-US" sz="1250" dirty="0"/>
           </a:p>
@@ -8698,7 +8698,7 @@
                 <a:ea typeface="Cambria" pitchFamily="34" charset="-122"/>
                 <a:cs typeface="Cambria" pitchFamily="34" charset="-120"/>
               </a:rPr>
-              <a:t>151,072</a:t>
+              <a:t>151,081</a:t>
             </a:r>
             <a:endParaRPr lang="en-US" sz="3600" dirty="0"/>
           </a:p>
@@ -8773,7 +8773,7 @@
                   <a:schemeClr val="tx1"/>
                 </a:solidFill>
               </a:rPr>
-              <a:t>Base REES46 (Kaggle): </a:t>
+              <a:t>REES46 (Kaggle): </a:t>
             </a:r>
             <a:pPr indent="0" marL="0">
               <a:spcAft>
@@ -8787,7 +8787,7 @@
                   <a:schemeClr val="tx2"/>
                 </a:solidFill>
               </a:rPr>
-              <a:t>event_time, event_type, product_id, category_code, brand, price, user_id, user_session. Embudo vista → carrito → compra, popularidad Zipf y sesiones por categorías afines.</a:t>
+              <a:t>DuckDB lee 2019-Oct.csv (5,7 GB) en streaming y toma los primeros 10M eventos en orden temporal: event_time, event_type, product_id, category_code, brand, price, user_id, user_session. El 95,6 % son vistas.</a:t>
             </a:r>
             <a:endParaRPr lang="en-US" sz="1800" dirty="0"/>
           </a:p>
@@ -8835,7 +8835,7 @@
                   <a:schemeClr val="tx1"/>
                 </a:solidFill>
               </a:rPr>
-              <a:t>Nota: </a:t>
+              <a:t>Experimentos de escalabilidad: </a:t>
             </a:r>
             <a:pPr indent="0" marL="0">
               <a:spcAft>
@@ -8849,7 +8849,7 @@
                   <a:schemeClr val="tx2"/>
                 </a:solidFill>
               </a:rPr>
-              <a:t>el entorno de ejecución no tenía acceso a Kaggle, por eso las corridas usan el generador con el mismo esquema. Con los CSV en data/raw/ el mismo comando corre sobre el dataset real.</a:t>
+              <a:t>usan entradas generadas para controlar n y conocer la respuesta exacta; el pipeline completo corre sobre los datos reales.</a:t>
             </a:r>
             <a:endParaRPr lang="en-US" sz="1800" dirty="0"/>
           </a:p>
@@ -9649,7 +9649,7 @@
                 <a:ea typeface="Cambria" pitchFamily="34" charset="-122"/>
                 <a:cs typeface="Cambria" pitchFamily="34" charset="-120"/>
               </a:rPr>
-              <a:t>151,072</a:t>
+              <a:t>151,081</a:t>
             </a:r>
             <a:endParaRPr lang="en-US" sz="3000" dirty="0"/>
           </a:p>
@@ -9685,7 +9685,7 @@
                   <a:schemeClr val="tx2"/>
                 </a:solidFill>
               </a:rPr>
-              <a:t>duplicados eliminados, 151,072 reales</a:t>
+              <a:t>duplicados eliminados, 151,081 reales</a:t>
             </a:r>
             <a:endParaRPr lang="en-US" sz="1150" dirty="0"/>
           </a:p>
@@ -9929,7 +9929,7 @@
                 <a:ea typeface="Cambria" pitchFamily="34" charset="-122"/>
                 <a:cs typeface="Cambria" pitchFamily="34" charset="-120"/>
               </a:rPr>
-              <a:t>87,216</a:t>
+              <a:t>76,348</a:t>
             </a:r>
             <a:endParaRPr lang="en-US" sz="3000" dirty="0"/>
           </a:p>
@@ -10278,7 +10278,7 @@
                   <a:schemeClr val="tx2"/>
                 </a:solidFill>
               </a:rPr>
-              <a:t>Matriz usuario × producto: 8,441,002 celdas</a:t>
+              <a:t>Matriz usuario × producto: 5,808,668 celdas</a:t>
             </a:r>
             <a:endParaRPr lang="en-US" sz="1500" dirty="0"/>
           </a:p>
@@ -11207,7 +11207,7 @@
                 <a:ea typeface="Cambria" pitchFamily="34" charset="-122"/>
                 <a:cs typeface="Cambria" pitchFamily="34" charset="-120"/>
               </a:rPr>
-              <a:t>99.998 %</a:t>
+              <a:t>92.9 %</a:t>
             </a:r>
             <a:endParaRPr lang="en-US" sz="3600" dirty="0"/>
           </a:p>
@@ -11243,7 +11243,7 @@
                   <a:schemeClr val="tx2"/>
                 </a:solidFill>
               </a:rPr>
-              <a:t>precisión del filtro</a:t>
+              <a:t>precisión: lo demás son cuentas reales con ráfagas de compra</a:t>
             </a:r>
             <a:endParaRPr lang="en-US" sz="1250" dirty="0"/>
           </a:p>
@@ -11282,7 +11282,7 @@
                 <a:ea typeface="Cambria" pitchFamily="34" charset="-122"/>
                 <a:cs typeface="Cambria" pitchFamily="34" charset="-120"/>
               </a:rPr>
-              <a:t>90.8 %</a:t>
+              <a:t>91.1 %</a:t>
             </a:r>
             <a:endParaRPr lang="en-US" sz="3600" dirty="0"/>
           </a:p>
@@ -11432,7 +11432,7 @@
                 <a:ea typeface="Cambria" pitchFamily="34" charset="-122"/>
                 <a:cs typeface="Cambria" pitchFamily="34" charset="-120"/>
               </a:rPr>
-              <a:t>10</a:t>
+              <a:t>7</a:t>
             </a:r>
             <a:endParaRPr lang="en-US" sz="3600" dirty="0"/>
           </a:p>
@@ -12349,7 +12349,7 @@
                 <a:ea typeface="Cambria" pitchFamily="34" charset="-122"/>
                 <a:cs typeface="Cambria" pitchFamily="34" charset="-120"/>
               </a:rPr>
-              <a:t>58,820</a:t>
+              <a:t>6,901</a:t>
             </a:r>
             <a:endParaRPr lang="en-US" sz="3600" dirty="0"/>
           </a:p>
@@ -12385,7 +12385,7 @@
                   <a:schemeClr val="tx2"/>
                 </a:solidFill>
               </a:rPr>
-              <a:t>productos y 258,638 aristas en la corrida de 10M</a:t>
+              <a:t>productos y 14,035 aristas en la corrida de 10M</a:t>
             </a:r>
             <a:endParaRPr lang="en-US" sz="1250" dirty="0"/>
           </a:p>
@@ -12424,7 +12424,7 @@
                 <a:ea typeface="Cambria" pitchFamily="34" charset="-122"/>
                 <a:cs typeface="Cambria" pitchFamily="34" charset="-120"/>
               </a:rPr>
-              <a:t>0.62 s</a:t>
+              <a:t>0.13 s</a:t>
             </a:r>
             <a:endParaRPr lang="en-US" sz="3600" dirty="0"/>
           </a:p>
@@ -12460,7 +12460,7 @@
                   <a:schemeClr val="tx2"/>
                 </a:solidFill>
               </a:rPr>
-              <a:t>PageRank, 74 iteraciones</a:t>
+              <a:t>PageRank, 89 iteraciones</a:t>
             </a:r>
             <a:endParaRPr lang="en-US" sz="1250" dirty="0"/>
           </a:p>

</xml_diff>